<commit_message>
updated info for AY 2025-26
</commit_message>
<xml_diff>
--- a/theory_12-regulation_on_data_protection/theory_12-regulation_on_data_protection.pptx
+++ b/theory_12-regulation_on_data_protection/theory_12-regulation_on_data_protection.pptx
@@ -142,6 +142,9 @@
     <p:ext uri="{EFAFB233-063F-42B5-8137-9DF3F51BA10A}">
       <p15:sldGuideLst xmlns:p15="http://schemas.microsoft.com/office/powerpoint/2012/main"/>
     </p:ext>
+    <p:ext uri="{2D200454-40CA-4A62-9FC3-DE9A4176ACB9}">
+      <p15:notesGuideLst xmlns:p15="http://schemas.microsoft.com/office/powerpoint/2012/main"/>
+    </p:ext>
   </p:extLst>
 </p:presentation>
 </file>
@@ -228,7 +231,7 @@
           <a:p>
             <a:fld id="{251090E0-FB0C-49E9-9864-9F53EABEA96F}" type="datetimeFigureOut">
               <a:rPr lang="en-GB" smtClean="0"/>
-              <a:t>05/05/2025</a:t>
+              <a:t>08/01/2026</a:t>
             </a:fld>
             <a:endParaRPr lang="en-GB"/>
           </a:p>
@@ -16655,7 +16658,7 @@
               <a:rPr lang="en-GB" smtClean="0"/>
               <a:t>4</a:t>
             </a:fld>
-            <a:endParaRPr lang="en-GB"/>
+            <a:endParaRPr lang="en-GB" dirty="0"/>
           </a:p>
         </p:txBody>
       </p:sp>

</xml_diff>